<commit_message>
feat(metadata): update official SRIP title, student Hithesh H G, guide Dr. Keerthana B Chigateri, and proxy routing
</commit_message>
<xml_diff>
--- a/Acoustic_DoA_Internship_Presentation.pptx
+++ b/Acoustic_DoA_Internship_Presentation.pptx
@@ -3166,22 +3166,26 @@
           <a:p>
             <a:pPr>
               <a:spcAft>
-                <a:spcPts val="1400"/>
-              </a:spcAft>
-              <a:defRPr sz="1300" b="1">
+                <a:spcPts val="1200"/>
+              </a:spcAft>
+              <a:defRPr sz="1200" b="1">
                 <a:solidFill>
                   <a:srgbClr val="00B4D8"/>
                 </a:solidFill>
               </a:defRPr>
             </a:pPr>
             <a:r>
-              <a:t>RESEARCH INTERNSHIP FINAL PROJECT DEFENSE</a:t>
-            </a:r>
-          </a:p>
-          <a:p>
-            <a:pPr>
-              <a:spcAft>
-                <a:spcPts val="1400"/>
+              <a:t>NITTE (DEEMED TO BE UNIVERSITY) • NMAM INSTITUTE OF TECHNOLOGY</a:t>
+            </a:r>
+            <a:br/>
+            <a:r>
+              <a:t>SUMMER RESEARCH INTERNSHIP PROGRAMME (SRIP 2025–26)</a:t>
+            </a:r>
+          </a:p>
+          <a:p>
+            <a:pPr>
+              <a:spcAft>
+                <a:spcPts val="1200"/>
               </a:spcAft>
               <a:defRPr sz="2800" b="1">
                 <a:solidFill>
@@ -3190,11 +3194,11 @@
               </a:defRPr>
             </a:pPr>
             <a:r>
-              <a:t>Acoustic Direction of Arrival (DoA) Estimation</a:t>
+              <a:t>Sound Direction Estimation using</a:t>
             </a:r>
             <a:br/>
             <a:r>
-              <a:t>on ESP32 Using Dual Sensors &amp; Quantized TinyML</a:t>
+              <a:t>Machine Learning and TinyML</a:t>
             </a:r>
           </a:p>
           <a:p>
@@ -3206,7 +3210,7 @@
               </a:defRPr>
             </a:pPr>
             <a:r>
-              <a:t>Ultra-Low-Power Embedded Edge AI • 10 cm Baseline • 31-Point Normalized Cross-Correlation</a:t>
+              <a:t>Edge AI &amp; Sub-Millisecond TinyML Direction of Arrival on ESP32 Microcontroller</a:t>
             </a:r>
           </a:p>
         </p:txBody>
@@ -3483,8 +3487,8 @@
         </p:nvSpPr>
         <p:spPr>
           <a:xfrm>
-            <a:off x="914400" y="5486400"/>
-            <a:ext cx="10362895" cy="731520"/>
+            <a:off x="914400" y="5394960"/>
+            <a:ext cx="10362895" cy="1005840"/>
           </a:xfrm>
           <a:prstGeom prst="rect">
             <a:avLst/>
@@ -3498,14 +3502,26 @@
           <a:lstStyle/>
           <a:p>
             <a:pPr>
-              <a:defRPr sz="1100">
+              <a:defRPr sz="1150" b="1">
+                <a:solidFill>
+                  <a:srgbClr val="DCEBFF"/>
+                </a:solidFill>
+              </a:defRPr>
+            </a:pPr>
+            <a:r>
+              <a:t>Student: Hithesh H G (USN: NNM23CS084)  |  Guide: Dr. Keerthana B Chigateri  |  Dept. of Computer Science &amp; Engineering (CSE)</a:t>
+            </a:r>
+          </a:p>
+          <a:p>
+            <a:pPr>
+              <a:defRPr sz="1000">
                 <a:solidFill>
                   <a:srgbClr val="A0B9D2"/>
                 </a:solidFill>
               </a:defRPr>
             </a:pPr>
             <a:r>
-              <a:t>Author: Embedded AI &amp; TinyML Research Group  |  Platform: ESP32 (Xtensa Dual-Core @ 240 MHz)  |  Target: MAX9814 Electret Array</a:t>
+              <a:t>NMAM Institute of Technology, Nitte (Deemed to be University)  •  Progress Presentation: 26 Sept 2026, 11:00 AM – 11:15 AM (LH211 APJ Block)</a:t>
             </a:r>
           </a:p>
         </p:txBody>
@@ -3558,7 +3574,7 @@
               </a:defRPr>
             </a:pPr>
             <a:r>
-              <a:t>RESEARCH INTERNSHIP PROJECT DEFENSE</a:t>
+              <a:t>NITTE NMAMIT • SRIP 2025–26 FINAL PROGRESS PRESENTATION</a:t>
             </a:r>
           </a:p>
         </p:txBody>
@@ -3645,7 +3661,42 @@
       </p:sp>
       <p:sp>
         <p:nvSpPr>
-          <p:cNvPr id="5" name="Rounded Rectangle 4"/>
+          <p:cNvPr id="5" name="TextBox 4"/>
+          <p:cNvSpPr txBox="1"/>
+          <p:nvPr/>
+        </p:nvSpPr>
+        <p:spPr>
+          <a:xfrm>
+            <a:off x="731520" y="6446520"/>
+            <a:ext cx="10728655" cy="320040"/>
+          </a:xfrm>
+          <a:prstGeom prst="rect">
+            <a:avLst/>
+          </a:prstGeom>
+          <a:noFill/>
+        </p:spPr>
+        <p:txBody>
+          <a:bodyPr wrap="none">
+            <a:spAutoFit/>
+          </a:bodyPr>
+          <a:lstStyle/>
+          <a:p>
+            <a:pPr>
+              <a:defRPr sz="850">
+                <a:solidFill>
+                  <a:srgbClr val="6C757D"/>
+                </a:solidFill>
+              </a:defRPr>
+            </a:pPr>
+            <a:r>
+              <a:t>Hithesh H G (NNM23CS084) | Guide: Dr. Keerthana B Chigateri | CSE, NMAMIT Nitte | Ref: 2026/NMAMIT/R&amp;D/07</a:t>
+            </a:r>
+          </a:p>
+        </p:txBody>
+      </p:sp>
+      <p:sp>
+        <p:nvSpPr>
+          <p:cNvPr id="6" name="Rounded Rectangle 5"/>
           <p:cNvSpPr/>
           <p:nvPr/>
         </p:nvSpPr>
@@ -3690,7 +3741,7 @@
       </p:sp>
       <p:pic>
         <p:nvPicPr>
-          <p:cNvPr id="6" name="Picture 5" descr="fig5_hardware_profiling_benchmark.png"/>
+          <p:cNvPr id="7" name="Picture 6" descr="fig5_hardware_profiling_benchmark.png"/>
           <p:cNvPicPr>
             <a:picLocks noChangeAspect="1"/>
           </p:cNvPicPr>
@@ -3714,7 +3765,7 @@
       </p:pic>
       <p:sp>
         <p:nvSpPr>
-          <p:cNvPr id="7" name="Rounded Rectangle 6"/>
+          <p:cNvPr id="8" name="Rounded Rectangle 7"/>
           <p:cNvSpPr/>
           <p:nvPr/>
         </p:nvSpPr>
@@ -3759,7 +3810,7 @@
       </p:sp>
       <p:sp>
         <p:nvSpPr>
-          <p:cNvPr id="8" name="TextBox 7"/>
+          <p:cNvPr id="9" name="TextBox 8"/>
           <p:cNvSpPr txBox="1"/>
           <p:nvPr/>
         </p:nvSpPr>
@@ -3925,7 +3976,7 @@
               </a:defRPr>
             </a:pPr>
             <a:r>
-              <a:t>RESEARCH INTERNSHIP PROJECT DEFENSE</a:t>
+              <a:t>NITTE NMAMIT • SRIP 2025–26 FINAL PROGRESS PRESENTATION</a:t>
             </a:r>
           </a:p>
         </p:txBody>
@@ -4012,7 +4063,42 @@
       </p:sp>
       <p:sp>
         <p:nvSpPr>
-          <p:cNvPr id="5" name="Rounded Rectangle 4"/>
+          <p:cNvPr id="5" name="TextBox 4"/>
+          <p:cNvSpPr txBox="1"/>
+          <p:nvPr/>
+        </p:nvSpPr>
+        <p:spPr>
+          <a:xfrm>
+            <a:off x="731520" y="6446520"/>
+            <a:ext cx="10728655" cy="320040"/>
+          </a:xfrm>
+          <a:prstGeom prst="rect">
+            <a:avLst/>
+          </a:prstGeom>
+          <a:noFill/>
+        </p:spPr>
+        <p:txBody>
+          <a:bodyPr wrap="none">
+            <a:spAutoFit/>
+          </a:bodyPr>
+          <a:lstStyle/>
+          <a:p>
+            <a:pPr>
+              <a:defRPr sz="850">
+                <a:solidFill>
+                  <a:srgbClr val="6C757D"/>
+                </a:solidFill>
+              </a:defRPr>
+            </a:pPr>
+            <a:r>
+              <a:t>Hithesh H G (NNM23CS084) | Guide: Dr. Keerthana B Chigateri | CSE, NMAMIT Nitte | Ref: 2026/NMAMIT/R&amp;D/07</a:t>
+            </a:r>
+          </a:p>
+        </p:txBody>
+      </p:sp>
+      <p:sp>
+        <p:nvSpPr>
+          <p:cNvPr id="6" name="Rounded Rectangle 5"/>
           <p:cNvSpPr/>
           <p:nvPr/>
         </p:nvSpPr>
@@ -4057,7 +4143,7 @@
       </p:sp>
       <p:sp>
         <p:nvSpPr>
-          <p:cNvPr id="6" name="TextBox 5"/>
+          <p:cNvPr id="7" name="TextBox 6"/>
           <p:cNvSpPr txBox="1"/>
           <p:nvPr/>
         </p:nvSpPr>
@@ -4139,7 +4225,7 @@
       </p:sp>
       <p:sp>
         <p:nvSpPr>
-          <p:cNvPr id="7" name="Rounded Rectangle 6"/>
+          <p:cNvPr id="8" name="Rounded Rectangle 7"/>
           <p:cNvSpPr/>
           <p:nvPr/>
         </p:nvSpPr>
@@ -4184,7 +4270,7 @@
       </p:sp>
       <p:sp>
         <p:nvSpPr>
-          <p:cNvPr id="8" name="TextBox 7"/>
+          <p:cNvPr id="9" name="TextBox 8"/>
           <p:cNvSpPr txBox="1"/>
           <p:nvPr/>
         </p:nvSpPr>
@@ -4277,7 +4363,7 @@
       </p:sp>
       <p:sp>
         <p:nvSpPr>
-          <p:cNvPr id="9" name="Rounded Rectangle 8"/>
+          <p:cNvPr id="10" name="Rounded Rectangle 9"/>
           <p:cNvSpPr/>
           <p:nvPr/>
         </p:nvSpPr>
@@ -4322,7 +4408,7 @@
       </p:sp>
       <p:sp>
         <p:nvSpPr>
-          <p:cNvPr id="10" name="TextBox 9"/>
+          <p:cNvPr id="11" name="TextBox 10"/>
           <p:cNvSpPr txBox="1"/>
           <p:nvPr/>
         </p:nvSpPr>
@@ -4450,7 +4536,7 @@
               </a:defRPr>
             </a:pPr>
             <a:r>
-              <a:t>RESEARCH INTERNSHIP PROJECT DEFENSE</a:t>
+              <a:t>NITTE NMAMIT • SRIP 2025–26 FINAL PROGRESS PRESENTATION</a:t>
             </a:r>
           </a:p>
         </p:txBody>
@@ -4537,7 +4623,42 @@
       </p:sp>
       <p:sp>
         <p:nvSpPr>
-          <p:cNvPr id="5" name="Rounded Rectangle 4"/>
+          <p:cNvPr id="5" name="TextBox 4"/>
+          <p:cNvSpPr txBox="1"/>
+          <p:nvPr/>
+        </p:nvSpPr>
+        <p:spPr>
+          <a:xfrm>
+            <a:off x="731520" y="6446520"/>
+            <a:ext cx="10728655" cy="320040"/>
+          </a:xfrm>
+          <a:prstGeom prst="rect">
+            <a:avLst/>
+          </a:prstGeom>
+          <a:noFill/>
+        </p:spPr>
+        <p:txBody>
+          <a:bodyPr wrap="none">
+            <a:spAutoFit/>
+          </a:bodyPr>
+          <a:lstStyle/>
+          <a:p>
+            <a:pPr>
+              <a:defRPr sz="850">
+                <a:solidFill>
+                  <a:srgbClr val="6C757D"/>
+                </a:solidFill>
+              </a:defRPr>
+            </a:pPr>
+            <a:r>
+              <a:t>Hithesh H G (NNM23CS084) | Guide: Dr. Keerthana B Chigateri | CSE, NMAMIT Nitte | Ref: 2026/NMAMIT/R&amp;D/07</a:t>
+            </a:r>
+          </a:p>
+        </p:txBody>
+      </p:sp>
+      <p:sp>
+        <p:nvSpPr>
+          <p:cNvPr id="6" name="Rounded Rectangle 5"/>
           <p:cNvSpPr/>
           <p:nvPr/>
         </p:nvSpPr>
@@ -4582,7 +4703,7 @@
       </p:sp>
       <p:sp>
         <p:nvSpPr>
-          <p:cNvPr id="6" name="TextBox 5"/>
+          <p:cNvPr id="7" name="TextBox 6"/>
           <p:cNvSpPr txBox="1"/>
           <p:nvPr/>
         </p:nvSpPr>
@@ -4675,7 +4796,7 @@
       </p:sp>
       <p:sp>
         <p:nvSpPr>
-          <p:cNvPr id="7" name="Rounded Rectangle 6"/>
+          <p:cNvPr id="8" name="Rounded Rectangle 7"/>
           <p:cNvSpPr/>
           <p:nvPr/>
         </p:nvSpPr>
@@ -4720,7 +4841,7 @@
       </p:sp>
       <p:sp>
         <p:nvSpPr>
-          <p:cNvPr id="8" name="TextBox 7"/>
+          <p:cNvPr id="9" name="TextBox 8"/>
           <p:cNvSpPr txBox="1"/>
           <p:nvPr/>
         </p:nvSpPr>
@@ -4881,7 +5002,7 @@
               </a:defRPr>
             </a:pPr>
             <a:r>
-              <a:t>RESEARCH INTERNSHIP PROJECT DEFENSE</a:t>
+              <a:t>NITTE NMAMIT • SRIP 2025–26 FINAL PROGRESS PRESENTATION</a:t>
             </a:r>
           </a:p>
         </p:txBody>
@@ -4968,7 +5089,42 @@
       </p:sp>
       <p:sp>
         <p:nvSpPr>
-          <p:cNvPr id="5" name="Rounded Rectangle 4"/>
+          <p:cNvPr id="5" name="TextBox 4"/>
+          <p:cNvSpPr txBox="1"/>
+          <p:nvPr/>
+        </p:nvSpPr>
+        <p:spPr>
+          <a:xfrm>
+            <a:off x="731520" y="6446520"/>
+            <a:ext cx="10728655" cy="320040"/>
+          </a:xfrm>
+          <a:prstGeom prst="rect">
+            <a:avLst/>
+          </a:prstGeom>
+          <a:noFill/>
+        </p:spPr>
+        <p:txBody>
+          <a:bodyPr wrap="none">
+            <a:spAutoFit/>
+          </a:bodyPr>
+          <a:lstStyle/>
+          <a:p>
+            <a:pPr>
+              <a:defRPr sz="850">
+                <a:solidFill>
+                  <a:srgbClr val="6C757D"/>
+                </a:solidFill>
+              </a:defRPr>
+            </a:pPr>
+            <a:r>
+              <a:t>Hithesh H G (NNM23CS084) | Guide: Dr. Keerthana B Chigateri | CSE, NMAMIT Nitte | Ref: 2026/NMAMIT/R&amp;D/07</a:t>
+            </a:r>
+          </a:p>
+        </p:txBody>
+      </p:sp>
+      <p:sp>
+        <p:nvSpPr>
+          <p:cNvPr id="6" name="Rounded Rectangle 5"/>
           <p:cNvSpPr/>
           <p:nvPr/>
         </p:nvSpPr>
@@ -5013,7 +5169,7 @@
       </p:sp>
       <p:sp>
         <p:nvSpPr>
-          <p:cNvPr id="6" name="TextBox 5"/>
+          <p:cNvPr id="7" name="TextBox 6"/>
           <p:cNvSpPr txBox="1"/>
           <p:nvPr/>
         </p:nvSpPr>
@@ -5126,7 +5282,7 @@
       </p:sp>
       <p:sp>
         <p:nvSpPr>
-          <p:cNvPr id="7" name="Rounded Rectangle 6"/>
+          <p:cNvPr id="8" name="Rounded Rectangle 7"/>
           <p:cNvSpPr/>
           <p:nvPr/>
         </p:nvSpPr>
@@ -5171,7 +5327,7 @@
       </p:sp>
       <p:sp>
         <p:nvSpPr>
-          <p:cNvPr id="8" name="TextBox 7"/>
+          <p:cNvPr id="9" name="TextBox 8"/>
           <p:cNvSpPr txBox="1"/>
           <p:nvPr/>
         </p:nvSpPr>
@@ -5330,7 +5486,7 @@
               </a:defRPr>
             </a:pPr>
             <a:r>
-              <a:t>RESEARCH INTERNSHIP PROJECT DEFENSE</a:t>
+              <a:t>NITTE NMAMIT • SRIP 2025–26 FINAL PROGRESS PRESENTATION</a:t>
             </a:r>
           </a:p>
         </p:txBody>
@@ -5417,7 +5573,42 @@
       </p:sp>
       <p:sp>
         <p:nvSpPr>
-          <p:cNvPr id="5" name="Rounded Rectangle 4"/>
+          <p:cNvPr id="5" name="TextBox 4"/>
+          <p:cNvSpPr txBox="1"/>
+          <p:nvPr/>
+        </p:nvSpPr>
+        <p:spPr>
+          <a:xfrm>
+            <a:off x="731520" y="6446520"/>
+            <a:ext cx="10728655" cy="320040"/>
+          </a:xfrm>
+          <a:prstGeom prst="rect">
+            <a:avLst/>
+          </a:prstGeom>
+          <a:noFill/>
+        </p:spPr>
+        <p:txBody>
+          <a:bodyPr wrap="none">
+            <a:spAutoFit/>
+          </a:bodyPr>
+          <a:lstStyle/>
+          <a:p>
+            <a:pPr>
+              <a:defRPr sz="850">
+                <a:solidFill>
+                  <a:srgbClr val="6C757D"/>
+                </a:solidFill>
+              </a:defRPr>
+            </a:pPr>
+            <a:r>
+              <a:t>Hithesh H G (NNM23CS084) | Guide: Dr. Keerthana B Chigateri | CSE, NMAMIT Nitte | Ref: 2026/NMAMIT/R&amp;D/07</a:t>
+            </a:r>
+          </a:p>
+        </p:txBody>
+      </p:sp>
+      <p:sp>
+        <p:nvSpPr>
+          <p:cNvPr id="6" name="Rounded Rectangle 5"/>
           <p:cNvSpPr/>
           <p:nvPr/>
         </p:nvSpPr>
@@ -5462,7 +5653,7 @@
       </p:sp>
       <p:pic>
         <p:nvPicPr>
-          <p:cNvPr id="6" name="Picture 5" descr="fig2_tdoa_geometry.png"/>
+          <p:cNvPr id="7" name="Picture 6" descr="fig2_tdoa_geometry.png"/>
           <p:cNvPicPr>
             <a:picLocks noChangeAspect="1"/>
           </p:cNvPicPr>
@@ -5486,7 +5677,7 @@
       </p:pic>
       <p:sp>
         <p:nvSpPr>
-          <p:cNvPr id="7" name="Rounded Rectangle 6"/>
+          <p:cNvPr id="8" name="Rounded Rectangle 7"/>
           <p:cNvSpPr/>
           <p:nvPr/>
         </p:nvSpPr>
@@ -5531,7 +5722,7 @@
       </p:sp>
       <p:sp>
         <p:nvSpPr>
-          <p:cNvPr id="8" name="TextBox 7"/>
+          <p:cNvPr id="9" name="TextBox 8"/>
           <p:cNvSpPr txBox="1"/>
           <p:nvPr/>
         </p:nvSpPr>
@@ -5735,7 +5926,7 @@
               </a:defRPr>
             </a:pPr>
             <a:r>
-              <a:t>RESEARCH INTERNSHIP PROJECT DEFENSE</a:t>
+              <a:t>NITTE NMAMIT • SRIP 2025–26 FINAL PROGRESS PRESENTATION</a:t>
             </a:r>
           </a:p>
         </p:txBody>
@@ -5822,7 +6013,42 @@
       </p:sp>
       <p:sp>
         <p:nvSpPr>
-          <p:cNvPr id="5" name="Rounded Rectangle 4"/>
+          <p:cNvPr id="5" name="TextBox 4"/>
+          <p:cNvSpPr txBox="1"/>
+          <p:nvPr/>
+        </p:nvSpPr>
+        <p:spPr>
+          <a:xfrm>
+            <a:off x="731520" y="6446520"/>
+            <a:ext cx="10728655" cy="320040"/>
+          </a:xfrm>
+          <a:prstGeom prst="rect">
+            <a:avLst/>
+          </a:prstGeom>
+          <a:noFill/>
+        </p:spPr>
+        <p:txBody>
+          <a:bodyPr wrap="none">
+            <a:spAutoFit/>
+          </a:bodyPr>
+          <a:lstStyle/>
+          <a:p>
+            <a:pPr>
+              <a:defRPr sz="850">
+                <a:solidFill>
+                  <a:srgbClr val="6C757D"/>
+                </a:solidFill>
+              </a:defRPr>
+            </a:pPr>
+            <a:r>
+              <a:t>Hithesh H G (NNM23CS084) | Guide: Dr. Keerthana B Chigateri | CSE, NMAMIT Nitte | Ref: 2026/NMAMIT/R&amp;D/07</a:t>
+            </a:r>
+          </a:p>
+        </p:txBody>
+      </p:sp>
+      <p:sp>
+        <p:nvSpPr>
+          <p:cNvPr id="6" name="Rounded Rectangle 5"/>
           <p:cNvSpPr/>
           <p:nvPr/>
         </p:nvSpPr>
@@ -5867,7 +6093,7 @@
       </p:sp>
       <p:pic>
         <p:nvPicPr>
-          <p:cNvPr id="6" name="Picture 5" descr="fig1_system_architecture.png"/>
+          <p:cNvPr id="7" name="Picture 6" descr="fig1_system_architecture.png"/>
           <p:cNvPicPr>
             <a:picLocks noChangeAspect="1"/>
           </p:cNvPicPr>
@@ -5891,7 +6117,7 @@
       </p:pic>
       <p:sp>
         <p:nvSpPr>
-          <p:cNvPr id="7" name="Rounded Rectangle 6"/>
+          <p:cNvPr id="8" name="Rounded Rectangle 7"/>
           <p:cNvSpPr/>
           <p:nvPr/>
         </p:nvSpPr>
@@ -5936,7 +6162,7 @@
       </p:sp>
       <p:sp>
         <p:nvSpPr>
-          <p:cNvPr id="8" name="TextBox 7"/>
+          <p:cNvPr id="9" name="TextBox 8"/>
           <p:cNvSpPr txBox="1"/>
           <p:nvPr/>
         </p:nvSpPr>
@@ -6110,7 +6336,7 @@
               </a:defRPr>
             </a:pPr>
             <a:r>
-              <a:t>RESEARCH INTERNSHIP PROJECT DEFENSE</a:t>
+              <a:t>NITTE NMAMIT • SRIP 2025–26 FINAL PROGRESS PRESENTATION</a:t>
             </a:r>
           </a:p>
         </p:txBody>
@@ -6197,7 +6423,42 @@
       </p:sp>
       <p:sp>
         <p:nvSpPr>
-          <p:cNvPr id="5" name="Rounded Rectangle 4"/>
+          <p:cNvPr id="5" name="TextBox 4"/>
+          <p:cNvSpPr txBox="1"/>
+          <p:nvPr/>
+        </p:nvSpPr>
+        <p:spPr>
+          <a:xfrm>
+            <a:off x="731520" y="6446520"/>
+            <a:ext cx="10728655" cy="320040"/>
+          </a:xfrm>
+          <a:prstGeom prst="rect">
+            <a:avLst/>
+          </a:prstGeom>
+          <a:noFill/>
+        </p:spPr>
+        <p:txBody>
+          <a:bodyPr wrap="none">
+            <a:spAutoFit/>
+          </a:bodyPr>
+          <a:lstStyle/>
+          <a:p>
+            <a:pPr>
+              <a:defRPr sz="850">
+                <a:solidFill>
+                  <a:srgbClr val="6C757D"/>
+                </a:solidFill>
+              </a:defRPr>
+            </a:pPr>
+            <a:r>
+              <a:t>Hithesh H G (NNM23CS084) | Guide: Dr. Keerthana B Chigateri | CSE, NMAMIT Nitte | Ref: 2026/NMAMIT/R&amp;D/07</a:t>
+            </a:r>
+          </a:p>
+        </p:txBody>
+      </p:sp>
+      <p:sp>
+        <p:nvSpPr>
+          <p:cNvPr id="6" name="Rounded Rectangle 5"/>
           <p:cNvSpPr/>
           <p:nvPr/>
         </p:nvSpPr>
@@ -6242,7 +6503,7 @@
       </p:sp>
       <p:pic>
         <p:nvPicPr>
-          <p:cNvPr id="6" name="Picture 5" descr="fig6_ncc_spatial_curves.png"/>
+          <p:cNvPr id="7" name="Picture 6" descr="fig6_ncc_spatial_curves.png"/>
           <p:cNvPicPr>
             <a:picLocks noChangeAspect="1"/>
           </p:cNvPicPr>
@@ -6266,7 +6527,7 @@
       </p:pic>
       <p:sp>
         <p:nvSpPr>
-          <p:cNvPr id="7" name="Rounded Rectangle 6"/>
+          <p:cNvPr id="8" name="Rounded Rectangle 7"/>
           <p:cNvSpPr/>
           <p:nvPr/>
         </p:nvSpPr>
@@ -6311,7 +6572,7 @@
       </p:sp>
       <p:sp>
         <p:nvSpPr>
-          <p:cNvPr id="8" name="TextBox 7"/>
+          <p:cNvPr id="9" name="TextBox 8"/>
           <p:cNvSpPr txBox="1"/>
           <p:nvPr/>
         </p:nvSpPr>
@@ -6485,7 +6746,7 @@
               </a:defRPr>
             </a:pPr>
             <a:r>
-              <a:t>RESEARCH INTERNSHIP PROJECT DEFENSE</a:t>
+              <a:t>NITTE NMAMIT • SRIP 2025–26 FINAL PROGRESS PRESENTATION</a:t>
             </a:r>
           </a:p>
         </p:txBody>
@@ -6572,7 +6833,42 @@
       </p:sp>
       <p:sp>
         <p:nvSpPr>
-          <p:cNvPr id="5" name="Rounded Rectangle 4"/>
+          <p:cNvPr id="5" name="TextBox 4"/>
+          <p:cNvSpPr txBox="1"/>
+          <p:nvPr/>
+        </p:nvSpPr>
+        <p:spPr>
+          <a:xfrm>
+            <a:off x="731520" y="6446520"/>
+            <a:ext cx="10728655" cy="320040"/>
+          </a:xfrm>
+          <a:prstGeom prst="rect">
+            <a:avLst/>
+          </a:prstGeom>
+          <a:noFill/>
+        </p:spPr>
+        <p:txBody>
+          <a:bodyPr wrap="none">
+            <a:spAutoFit/>
+          </a:bodyPr>
+          <a:lstStyle/>
+          <a:p>
+            <a:pPr>
+              <a:defRPr sz="850">
+                <a:solidFill>
+                  <a:srgbClr val="6C757D"/>
+                </a:solidFill>
+              </a:defRPr>
+            </a:pPr>
+            <a:r>
+              <a:t>Hithesh H G (NNM23CS084) | Guide: Dr. Keerthana B Chigateri | CSE, NMAMIT Nitte | Ref: 2026/NMAMIT/R&amp;D/07</a:t>
+            </a:r>
+          </a:p>
+        </p:txBody>
+      </p:sp>
+      <p:sp>
+        <p:nvSpPr>
+          <p:cNvPr id="6" name="Rounded Rectangle 5"/>
           <p:cNvSpPr/>
           <p:nvPr/>
         </p:nvSpPr>
@@ -6617,7 +6913,7 @@
       </p:sp>
       <p:sp>
         <p:nvSpPr>
-          <p:cNvPr id="6" name="TextBox 5"/>
+          <p:cNvPr id="7" name="TextBox 6"/>
           <p:cNvSpPr txBox="1"/>
           <p:nvPr/>
         </p:nvSpPr>
@@ -6699,7 +6995,7 @@
       </p:sp>
       <p:sp>
         <p:nvSpPr>
-          <p:cNvPr id="7" name="Rounded Rectangle 6"/>
+          <p:cNvPr id="8" name="Rounded Rectangle 7"/>
           <p:cNvSpPr/>
           <p:nvPr/>
         </p:nvSpPr>
@@ -6744,7 +7040,7 @@
       </p:sp>
       <p:sp>
         <p:nvSpPr>
-          <p:cNvPr id="8" name="TextBox 7"/>
+          <p:cNvPr id="9" name="TextBox 8"/>
           <p:cNvSpPr txBox="1"/>
           <p:nvPr/>
         </p:nvSpPr>
@@ -6826,7 +7122,7 @@
       </p:sp>
       <p:sp>
         <p:nvSpPr>
-          <p:cNvPr id="9" name="Rounded Rectangle 8"/>
+          <p:cNvPr id="10" name="Rounded Rectangle 9"/>
           <p:cNvSpPr/>
           <p:nvPr/>
         </p:nvSpPr>
@@ -6871,7 +7167,7 @@
       </p:sp>
       <p:sp>
         <p:nvSpPr>
-          <p:cNvPr id="10" name="TextBox 9"/>
+          <p:cNvPr id="11" name="TextBox 10"/>
           <p:cNvSpPr txBox="1"/>
           <p:nvPr/>
         </p:nvSpPr>
@@ -7032,7 +7328,7 @@
               </a:defRPr>
             </a:pPr>
             <a:r>
-              <a:t>RESEARCH INTERNSHIP PROJECT DEFENSE</a:t>
+              <a:t>NITTE NMAMIT • SRIP 2025–26 FINAL PROGRESS PRESENTATION</a:t>
             </a:r>
           </a:p>
         </p:txBody>
@@ -7119,7 +7415,42 @@
       </p:sp>
       <p:sp>
         <p:nvSpPr>
-          <p:cNvPr id="5" name="Rounded Rectangle 4"/>
+          <p:cNvPr id="5" name="TextBox 4"/>
+          <p:cNvSpPr txBox="1"/>
+          <p:nvPr/>
+        </p:nvSpPr>
+        <p:spPr>
+          <a:xfrm>
+            <a:off x="731520" y="6446520"/>
+            <a:ext cx="10728655" cy="320040"/>
+          </a:xfrm>
+          <a:prstGeom prst="rect">
+            <a:avLst/>
+          </a:prstGeom>
+          <a:noFill/>
+        </p:spPr>
+        <p:txBody>
+          <a:bodyPr wrap="none">
+            <a:spAutoFit/>
+          </a:bodyPr>
+          <a:lstStyle/>
+          <a:p>
+            <a:pPr>
+              <a:defRPr sz="850">
+                <a:solidFill>
+                  <a:srgbClr val="6C757D"/>
+                </a:solidFill>
+              </a:defRPr>
+            </a:pPr>
+            <a:r>
+              <a:t>Hithesh H G (NNM23CS084) | Guide: Dr. Keerthana B Chigateri | CSE, NMAMIT Nitte | Ref: 2026/NMAMIT/R&amp;D/07</a:t>
+            </a:r>
+          </a:p>
+        </p:txBody>
+      </p:sp>
+      <p:sp>
+        <p:nvSpPr>
+          <p:cNvPr id="6" name="Rounded Rectangle 5"/>
           <p:cNvSpPr/>
           <p:nvPr/>
         </p:nvSpPr>
@@ -7164,7 +7495,7 @@
       </p:sp>
       <p:sp>
         <p:nvSpPr>
-          <p:cNvPr id="6" name="TextBox 5"/>
+          <p:cNvPr id="7" name="TextBox 6"/>
           <p:cNvSpPr txBox="1"/>
           <p:nvPr/>
         </p:nvSpPr>
@@ -7268,7 +7599,7 @@
       </p:sp>
       <p:sp>
         <p:nvSpPr>
-          <p:cNvPr id="7" name="Rounded Rectangle 6"/>
+          <p:cNvPr id="8" name="Rounded Rectangle 7"/>
           <p:cNvSpPr/>
           <p:nvPr/>
         </p:nvSpPr>
@@ -7313,7 +7644,7 @@
       </p:sp>
       <p:sp>
         <p:nvSpPr>
-          <p:cNvPr id="8" name="TextBox 7"/>
+          <p:cNvPr id="9" name="TextBox 8"/>
           <p:cNvSpPr txBox="1"/>
           <p:nvPr/>
         </p:nvSpPr>
@@ -7463,7 +7794,7 @@
               </a:defRPr>
             </a:pPr>
             <a:r>
-              <a:t>RESEARCH INTERNSHIP PROJECT DEFENSE</a:t>
+              <a:t>NITTE NMAMIT • SRIP 2025–26 FINAL PROGRESS PRESENTATION</a:t>
             </a:r>
           </a:p>
         </p:txBody>
@@ -7550,7 +7881,42 @@
       </p:sp>
       <p:sp>
         <p:nvSpPr>
-          <p:cNvPr id="5" name="Rounded Rectangle 4"/>
+          <p:cNvPr id="5" name="TextBox 4"/>
+          <p:cNvSpPr txBox="1"/>
+          <p:nvPr/>
+        </p:nvSpPr>
+        <p:spPr>
+          <a:xfrm>
+            <a:off x="731520" y="6446520"/>
+            <a:ext cx="10728655" cy="320040"/>
+          </a:xfrm>
+          <a:prstGeom prst="rect">
+            <a:avLst/>
+          </a:prstGeom>
+          <a:noFill/>
+        </p:spPr>
+        <p:txBody>
+          <a:bodyPr wrap="none">
+            <a:spAutoFit/>
+          </a:bodyPr>
+          <a:lstStyle/>
+          <a:p>
+            <a:pPr>
+              <a:defRPr sz="850">
+                <a:solidFill>
+                  <a:srgbClr val="6C757D"/>
+                </a:solidFill>
+              </a:defRPr>
+            </a:pPr>
+            <a:r>
+              <a:t>Hithesh H G (NNM23CS084) | Guide: Dr. Keerthana B Chigateri | CSE, NMAMIT Nitte | Ref: 2026/NMAMIT/R&amp;D/07</a:t>
+            </a:r>
+          </a:p>
+        </p:txBody>
+      </p:sp>
+      <p:sp>
+        <p:nvSpPr>
+          <p:cNvPr id="6" name="Rounded Rectangle 5"/>
           <p:cNvSpPr/>
           <p:nvPr/>
         </p:nvSpPr>
@@ -7595,7 +7961,7 @@
       </p:sp>
       <p:pic>
         <p:nvPicPr>
-          <p:cNvPr id="6" name="Picture 5" descr="fig3_dsp_flowchart.png"/>
+          <p:cNvPr id="7" name="Picture 6" descr="fig3_dsp_flowchart.png"/>
           <p:cNvPicPr>
             <a:picLocks noChangeAspect="1"/>
           </p:cNvPicPr>
@@ -7619,7 +7985,7 @@
       </p:pic>
       <p:sp>
         <p:nvSpPr>
-          <p:cNvPr id="7" name="Rounded Rectangle 6"/>
+          <p:cNvPr id="8" name="Rounded Rectangle 7"/>
           <p:cNvSpPr/>
           <p:nvPr/>
         </p:nvSpPr>
@@ -7664,7 +8030,7 @@
       </p:sp>
       <p:sp>
         <p:nvSpPr>
-          <p:cNvPr id="8" name="TextBox 7"/>
+          <p:cNvPr id="9" name="TextBox 8"/>
           <p:cNvSpPr txBox="1"/>
           <p:nvPr/>
         </p:nvSpPr>
@@ -7814,7 +8180,7 @@
               </a:defRPr>
             </a:pPr>
             <a:r>
-              <a:t>RESEARCH INTERNSHIP PROJECT DEFENSE</a:t>
+              <a:t>NITTE NMAMIT • SRIP 2025–26 FINAL PROGRESS PRESENTATION</a:t>
             </a:r>
           </a:p>
         </p:txBody>
@@ -7901,7 +8267,42 @@
       </p:sp>
       <p:sp>
         <p:nvSpPr>
-          <p:cNvPr id="5" name="Rounded Rectangle 4"/>
+          <p:cNvPr id="5" name="TextBox 4"/>
+          <p:cNvSpPr txBox="1"/>
+          <p:nvPr/>
+        </p:nvSpPr>
+        <p:spPr>
+          <a:xfrm>
+            <a:off x="731520" y="6446520"/>
+            <a:ext cx="10728655" cy="320040"/>
+          </a:xfrm>
+          <a:prstGeom prst="rect">
+            <a:avLst/>
+          </a:prstGeom>
+          <a:noFill/>
+        </p:spPr>
+        <p:txBody>
+          <a:bodyPr wrap="none">
+            <a:spAutoFit/>
+          </a:bodyPr>
+          <a:lstStyle/>
+          <a:p>
+            <a:pPr>
+              <a:defRPr sz="850">
+                <a:solidFill>
+                  <a:srgbClr val="6C757D"/>
+                </a:solidFill>
+              </a:defRPr>
+            </a:pPr>
+            <a:r>
+              <a:t>Hithesh H G (NNM23CS084) | Guide: Dr. Keerthana B Chigateri | CSE, NMAMIT Nitte | Ref: 2026/NMAMIT/R&amp;D/07</a:t>
+            </a:r>
+          </a:p>
+        </p:txBody>
+      </p:sp>
+      <p:sp>
+        <p:nvSpPr>
+          <p:cNvPr id="6" name="Rounded Rectangle 5"/>
           <p:cNvSpPr/>
           <p:nvPr/>
         </p:nvSpPr>
@@ -7946,7 +8347,7 @@
       </p:sp>
       <p:pic>
         <p:nvPicPr>
-          <p:cNvPr id="6" name="Picture 5" descr="fig4_confusion_matrix_and_metrics.png"/>
+          <p:cNvPr id="7" name="Picture 6" descr="fig4_confusion_matrix_and_metrics.png"/>
           <p:cNvPicPr>
             <a:picLocks noChangeAspect="1"/>
           </p:cNvPicPr>
@@ -7970,7 +8371,7 @@
       </p:pic>
       <p:sp>
         <p:nvSpPr>
-          <p:cNvPr id="7" name="Rounded Rectangle 6"/>
+          <p:cNvPr id="8" name="Rounded Rectangle 7"/>
           <p:cNvSpPr/>
           <p:nvPr/>
         </p:nvSpPr>
@@ -8015,7 +8416,7 @@
       </p:sp>
       <p:sp>
         <p:nvSpPr>
-          <p:cNvPr id="8" name="TextBox 7"/>
+          <p:cNvPr id="9" name="TextBox 8"/>
           <p:cNvSpPr txBox="1"/>
           <p:nvPr/>
         </p:nvSpPr>

</xml_diff>